<commit_message>
Update themed presentation deck
</commit_message>
<xml_diff>
--- a/docs/Everstage-QA-Presentation-Themed.pptx
+++ b/docs/Everstage-QA-Presentation-Themed.pptx
@@ -3164,7 +3164,7 @@
         </p:nvSpPr>
         <p:spPr>
           <a:xfrm>
-            <a:off x="822960" y="2468880"/>
+            <a:off x="822960" y="2286000"/>
             <a:ext cx="10058400" cy="365760"/>
           </a:xfrm>
           <a:prstGeom prst="rect">
@@ -3189,7 +3189,7 @@
                 <a:ea typeface="Calibri" pitchFamily="34" charset="-122"/>
                 <a:cs typeface="Calibri" pitchFamily="34" charset="-120"/>
               </a:rPr>
-              <a:t>QA  ENGINEERING  ASSESSMENT</a:t>
+              <a:t>QA  ENGINEERING  ASSESSMENT  ·  SUBMISSION</a:t>
             </a:r>
             <a:endParaRPr lang="en-US" sz="1300" dirty="0"/>
           </a:p>
@@ -3203,7 +3203,7 @@
         </p:nvSpPr>
         <p:spPr>
           <a:xfrm>
-            <a:off x="822960" y="2880360"/>
+            <a:off x="822960" y="2697480"/>
             <a:ext cx="10058400" cy="1280160"/>
           </a:xfrm>
           <a:prstGeom prst="rect">
@@ -3220,7 +3220,7 @@
               <a:buNone/>
             </a:pPr>
             <a:r>
-              <a:rPr lang="en-US" sz="6400" b="1" dirty="0">
+              <a:rPr lang="en-US" sz="6000" b="1" dirty="0">
                 <a:solidFill>
                   <a:srgbClr val="F8FAFC"/>
                 </a:solidFill>
@@ -3230,7 +3230,7 @@
               </a:rPr>
               <a:t>Juice Shop QA Automation</a:t>
             </a:r>
-            <a:endParaRPr lang="en-US" sz="6400" dirty="0"/>
+            <a:endParaRPr lang="en-US" sz="6000" dirty="0"/>
           </a:p>
         </p:txBody>
       </p:sp>
@@ -3242,7 +3242,7 @@
         </p:nvSpPr>
         <p:spPr>
           <a:xfrm>
-            <a:off x="822960" y="4251960"/>
+            <a:off x="822960" y="4023360"/>
             <a:ext cx="10058400" cy="457200"/>
           </a:xfrm>
           <a:prstGeom prst="rect">
@@ -3259,7 +3259,7 @@
               <a:buNone/>
             </a:pPr>
             <a:r>
-              <a:rPr lang="en-US" sz="2200" dirty="0">
+              <a:rPr lang="en-US" sz="2000" dirty="0">
                 <a:solidFill>
                   <a:srgbClr val="C7D2FE"/>
                 </a:solidFill>
@@ -3269,19 +3269,253 @@
               </a:rPr>
               <a:t>End-to-end test suite  ·  Playwright + TypeScript</a:t>
             </a:r>
-            <a:endParaRPr lang="en-US" sz="2200" dirty="0"/>
-          </a:p>
-        </p:txBody>
-      </p:sp>
-      <p:sp>
-        <p:nvSpPr>
-          <p:cNvPr id="31" name="Shape 29"/>
-          <p:cNvSpPr/>
-          <p:nvPr/>
-        </p:nvSpPr>
-        <p:spPr>
-          <a:xfrm>
-            <a:off x="822960" y="5212080"/>
+            <a:endParaRPr lang="en-US" sz="2000" dirty="0"/>
+          </a:p>
+        </p:txBody>
+      </p:sp>
+      <p:sp>
+        <p:nvSpPr>
+          <p:cNvPr id="31" name="Text 29"/>
+          <p:cNvSpPr/>
+          <p:nvPr/>
+        </p:nvSpPr>
+        <p:spPr>
+          <a:xfrm>
+            <a:off x="822960" y="4617720"/>
+            <a:ext cx="2286000" cy="548640"/>
+          </a:xfrm>
+          <a:prstGeom prst="rect">
+            <a:avLst/>
+          </a:prstGeom>
+          <a:noFill/>
+          <a:ln/>
+        </p:spPr>
+        <p:txBody>
+          <a:bodyPr wrap="square" lIns="0" tIns="0" rIns="0" bIns="0" rtlCol="0" anchor="ctr"/>
+          <a:lstStyle/>
+          <a:p>
+            <a:pPr indent="0" marL="0">
+              <a:buNone/>
+            </a:pPr>
+            <a:r>
+              <a:rPr lang="en-US" sz="3000" b="1" dirty="0">
+                <a:solidFill>
+                  <a:srgbClr val="5EE7FF"/>
+                </a:solidFill>
+                <a:latin typeface="Calibri" pitchFamily="34" charset="0"/>
+                <a:ea typeface="Calibri" pitchFamily="34" charset="-122"/>
+                <a:cs typeface="Calibri" pitchFamily="34" charset="-120"/>
+              </a:rPr>
+              <a:t>223 / 223</a:t>
+            </a:r>
+            <a:endParaRPr lang="en-US" sz="3000" dirty="0"/>
+          </a:p>
+        </p:txBody>
+      </p:sp>
+      <p:sp>
+        <p:nvSpPr>
+          <p:cNvPr id="32" name="Text 30"/>
+          <p:cNvSpPr/>
+          <p:nvPr/>
+        </p:nvSpPr>
+        <p:spPr>
+          <a:xfrm>
+            <a:off x="822960" y="5166360"/>
+            <a:ext cx="2286000" cy="274320"/>
+          </a:xfrm>
+          <a:prstGeom prst="rect">
+            <a:avLst/>
+          </a:prstGeom>
+          <a:noFill/>
+          <a:ln/>
+        </p:spPr>
+        <p:txBody>
+          <a:bodyPr wrap="square" lIns="0" tIns="0" rIns="0" bIns="0" rtlCol="0" anchor="ctr"/>
+          <a:lstStyle/>
+          <a:p>
+            <a:pPr indent="0" marL="0">
+              <a:buNone/>
+            </a:pPr>
+            <a:r>
+              <a:rPr lang="en-US" sz="1100" dirty="0">
+                <a:solidFill>
+                  <a:srgbClr val="C7D2FE"/>
+                </a:solidFill>
+                <a:latin typeface="Calibri" pitchFamily="34" charset="0"/>
+                <a:ea typeface="Calibri" pitchFamily="34" charset="-122"/>
+                <a:cs typeface="Calibri" pitchFamily="34" charset="-120"/>
+              </a:rPr>
+              <a:t>tests passing</a:t>
+            </a:r>
+            <a:endParaRPr lang="en-US" sz="1100" dirty="0"/>
+          </a:p>
+        </p:txBody>
+      </p:sp>
+      <p:sp>
+        <p:nvSpPr>
+          <p:cNvPr id="33" name="Text 31"/>
+          <p:cNvSpPr/>
+          <p:nvPr/>
+        </p:nvSpPr>
+        <p:spPr>
+          <a:xfrm>
+            <a:off x="3154680" y="4617720"/>
+            <a:ext cx="2286000" cy="548640"/>
+          </a:xfrm>
+          <a:prstGeom prst="rect">
+            <a:avLst/>
+          </a:prstGeom>
+          <a:noFill/>
+          <a:ln/>
+        </p:spPr>
+        <p:txBody>
+          <a:bodyPr wrap="square" lIns="0" tIns="0" rIns="0" bIns="0" rtlCol="0" anchor="ctr"/>
+          <a:lstStyle/>
+          <a:p>
+            <a:pPr indent="0" marL="0">
+              <a:buNone/>
+            </a:pPr>
+            <a:r>
+              <a:rPr lang="en-US" sz="3000" b="1" dirty="0">
+                <a:solidFill>
+                  <a:srgbClr val="5EE7FF"/>
+                </a:solidFill>
+                <a:latin typeface="Calibri" pitchFamily="34" charset="0"/>
+                <a:ea typeface="Calibri" pitchFamily="34" charset="-122"/>
+                <a:cs typeface="Calibri" pitchFamily="34" charset="-120"/>
+              </a:rPr>
+              <a:t>33</a:t>
+            </a:r>
+            <a:endParaRPr lang="en-US" sz="3000" dirty="0"/>
+          </a:p>
+        </p:txBody>
+      </p:sp>
+      <p:sp>
+        <p:nvSpPr>
+          <p:cNvPr id="34" name="Text 32"/>
+          <p:cNvSpPr/>
+          <p:nvPr/>
+        </p:nvSpPr>
+        <p:spPr>
+          <a:xfrm>
+            <a:off x="3154680" y="5166360"/>
+            <a:ext cx="2286000" cy="274320"/>
+          </a:xfrm>
+          <a:prstGeom prst="rect">
+            <a:avLst/>
+          </a:prstGeom>
+          <a:noFill/>
+          <a:ln/>
+        </p:spPr>
+        <p:txBody>
+          <a:bodyPr wrap="square" lIns="0" tIns="0" rIns="0" bIns="0" rtlCol="0" anchor="ctr"/>
+          <a:lstStyle/>
+          <a:p>
+            <a:pPr indent="0" marL="0">
+              <a:buNone/>
+            </a:pPr>
+            <a:r>
+              <a:rPr lang="en-US" sz="1100" dirty="0">
+                <a:solidFill>
+                  <a:srgbClr val="C7D2FE"/>
+                </a:solidFill>
+                <a:latin typeface="Calibri" pitchFamily="34" charset="0"/>
+                <a:ea typeface="Calibri" pitchFamily="34" charset="-122"/>
+                <a:cs typeface="Calibri" pitchFamily="34" charset="-120"/>
+              </a:rPr>
+              <a:t>bugs found</a:t>
+            </a:r>
+            <a:endParaRPr lang="en-US" sz="1100" dirty="0"/>
+          </a:p>
+        </p:txBody>
+      </p:sp>
+      <p:sp>
+        <p:nvSpPr>
+          <p:cNvPr id="35" name="Text 33"/>
+          <p:cNvSpPr/>
+          <p:nvPr/>
+        </p:nvSpPr>
+        <p:spPr>
+          <a:xfrm>
+            <a:off x="5486400" y="4617720"/>
+            <a:ext cx="2286000" cy="548640"/>
+          </a:xfrm>
+          <a:prstGeom prst="rect">
+            <a:avLst/>
+          </a:prstGeom>
+          <a:noFill/>
+          <a:ln/>
+        </p:spPr>
+        <p:txBody>
+          <a:bodyPr wrap="square" lIns="0" tIns="0" rIns="0" bIns="0" rtlCol="0" anchor="ctr"/>
+          <a:lstStyle/>
+          <a:p>
+            <a:pPr indent="0" marL="0">
+              <a:buNone/>
+            </a:pPr>
+            <a:r>
+              <a:rPr lang="en-US" sz="3000" b="1" dirty="0">
+                <a:solidFill>
+                  <a:srgbClr val="5EE7FF"/>
+                </a:solidFill>
+                <a:latin typeface="Calibri" pitchFamily="34" charset="0"/>
+                <a:ea typeface="Calibri" pitchFamily="34" charset="-122"/>
+                <a:cs typeface="Calibri" pitchFamily="34" charset="-120"/>
+              </a:rPr>
+              <a:t>2m 20s</a:t>
+            </a:r>
+            <a:endParaRPr lang="en-US" sz="3000" dirty="0"/>
+          </a:p>
+        </p:txBody>
+      </p:sp>
+      <p:sp>
+        <p:nvSpPr>
+          <p:cNvPr id="36" name="Text 34"/>
+          <p:cNvSpPr/>
+          <p:nvPr/>
+        </p:nvSpPr>
+        <p:spPr>
+          <a:xfrm>
+            <a:off x="5486400" y="5166360"/>
+            <a:ext cx="2286000" cy="274320"/>
+          </a:xfrm>
+          <a:prstGeom prst="rect">
+            <a:avLst/>
+          </a:prstGeom>
+          <a:noFill/>
+          <a:ln/>
+        </p:spPr>
+        <p:txBody>
+          <a:bodyPr wrap="square" lIns="0" tIns="0" rIns="0" bIns="0" rtlCol="0" anchor="ctr"/>
+          <a:lstStyle/>
+          <a:p>
+            <a:pPr indent="0" marL="0">
+              <a:buNone/>
+            </a:pPr>
+            <a:r>
+              <a:rPr lang="en-US" sz="1100" dirty="0">
+                <a:solidFill>
+                  <a:srgbClr val="C7D2FE"/>
+                </a:solidFill>
+                <a:latin typeface="Calibri" pitchFamily="34" charset="0"/>
+                <a:ea typeface="Calibri" pitchFamily="34" charset="-122"/>
+                <a:cs typeface="Calibri" pitchFamily="34" charset="-120"/>
+              </a:rPr>
+              <a:t>wall time</a:t>
+            </a:r>
+            <a:endParaRPr lang="en-US" sz="1100" dirty="0"/>
+          </a:p>
+        </p:txBody>
+      </p:sp>
+      <p:sp>
+        <p:nvSpPr>
+          <p:cNvPr id="37" name="Shape 35"/>
+          <p:cNvSpPr/>
+          <p:nvPr/>
+        </p:nvSpPr>
+        <p:spPr>
+          <a:xfrm>
+            <a:off x="822960" y="5715000"/>
             <a:ext cx="4572000" cy="45720"/>
           </a:xfrm>
           <a:prstGeom prst="rect">
@@ -3295,13 +3529,13 @@
       </p:sp>
       <p:sp>
         <p:nvSpPr>
-          <p:cNvPr id="32" name="Text 30"/>
-          <p:cNvSpPr/>
-          <p:nvPr/>
-        </p:nvSpPr>
-        <p:spPr>
-          <a:xfrm>
-            <a:off x="822960" y="5349240"/>
+          <p:cNvPr id="38" name="Text 36"/>
+          <p:cNvSpPr/>
+          <p:nvPr/>
+        </p:nvSpPr>
+        <p:spPr>
+          <a:xfrm>
+            <a:off x="822960" y="5852160"/>
             <a:ext cx="10058400" cy="365760"/>
           </a:xfrm>
           <a:prstGeom prst="rect">
@@ -3334,13 +3568,13 @@
       </p:sp>
       <p:sp>
         <p:nvSpPr>
-          <p:cNvPr id="33" name="Text 31"/>
-          <p:cNvSpPr/>
-          <p:nvPr/>
-        </p:nvSpPr>
-        <p:spPr>
-          <a:xfrm>
-            <a:off x="822960" y="5715000"/>
+          <p:cNvPr id="39" name="Text 37"/>
+          <p:cNvSpPr/>
+          <p:nvPr/>
+        </p:nvSpPr>
+        <p:spPr>
+          <a:xfrm>
+            <a:off x="822960" y="6199632"/>
             <a:ext cx="10058400" cy="274320"/>
           </a:xfrm>
           <a:prstGeom prst="rect">
@@ -3365,7 +3599,7 @@
                 <a:ea typeface="Calibri" pitchFamily="34" charset="-122"/>
                 <a:cs typeface="Calibri" pitchFamily="34" charset="-120"/>
               </a:rPr>
-              <a:t>Assessment submission deck  ·  ~25 minutes</a:t>
+              <a:t>10 May 2026  ·  Assessment submission deck  ·  ~25 minutes</a:t>
             </a:r>
             <a:endParaRPr lang="en-US" sz="1200" dirty="0"/>
           </a:p>
@@ -23359,24 +23593,24 @@
         </p:nvSpPr>
         <p:spPr>
           <a:xfrm>
-            <a:off x="822960" y="1691640"/>
-            <a:ext cx="10058400" cy="411480"/>
-          </a:xfrm>
-          <a:prstGeom prst="rect">
-            <a:avLst/>
-          </a:prstGeom>
-          <a:noFill/>
-          <a:ln/>
-        </p:spPr>
-        <p:txBody>
-          <a:bodyPr wrap="square" lIns="0" tIns="0" rIns="0" bIns="0" rtlCol="0" anchor="ctr"/>
-          <a:lstStyle/>
-          <a:p>
-            <a:pPr indent="0" marL="0">
-              <a:buNone/>
-            </a:pPr>
-            <a:r>
-              <a:rPr lang="en-US" sz="1400" b="1" spc="1200" kern="0" dirty="0">
+            <a:off x="0" y="2468880"/>
+            <a:ext cx="12191695" cy="457200"/>
+          </a:xfrm>
+          <a:prstGeom prst="rect">
+            <a:avLst/>
+          </a:prstGeom>
+          <a:noFill/>
+          <a:ln/>
+        </p:spPr>
+        <p:txBody>
+          <a:bodyPr wrap="square" lIns="0" tIns="0" rIns="0" bIns="0" rtlCol="0" anchor="ctr"/>
+          <a:lstStyle/>
+          <a:p>
+            <a:pPr algn="ctr" indent="0" marL="0">
+              <a:buNone/>
+            </a:pPr>
+            <a:r>
+              <a:rPr lang="en-US" sz="1600" b="1" spc="1600" kern="0" dirty="0">
                 <a:solidFill>
                   <a:srgbClr val="5EE7FF"/>
                 </a:solidFill>
@@ -23384,9 +23618,9 @@
                 <a:ea typeface="Calibri" pitchFamily="34" charset="-122"/>
                 <a:cs typeface="Calibri" pitchFamily="34" charset="-120"/>
               </a:rPr>
-              <a:t>THANK YOU</a:t>
-            </a:r>
-            <a:endParaRPr lang="en-US" sz="1400" dirty="0"/>
+              <a:t>THANK  YOU</a:t>
+            </a:r>
+            <a:endParaRPr lang="en-US" sz="1600" dirty="0"/>
           </a:p>
         </p:txBody>
       </p:sp>
@@ -23398,24 +23632,24 @@
         </p:nvSpPr>
         <p:spPr>
           <a:xfrm>
-            <a:off x="822960" y="2103120"/>
-            <a:ext cx="10058400" cy="914400"/>
-          </a:xfrm>
-          <a:prstGeom prst="rect">
-            <a:avLst/>
-          </a:prstGeom>
-          <a:noFill/>
-          <a:ln/>
-        </p:spPr>
-        <p:txBody>
-          <a:bodyPr wrap="square" lIns="0" tIns="0" rIns="0" bIns="0" rtlCol="0" anchor="ctr"/>
-          <a:lstStyle/>
-          <a:p>
-            <a:pPr indent="0" marL="0">
-              <a:buNone/>
-            </a:pPr>
-            <a:r>
-              <a:rPr lang="en-US" sz="4800" b="1" dirty="0">
+            <a:off x="0" y="2971800"/>
+            <a:ext cx="12191695" cy="1280160"/>
+          </a:xfrm>
+          <a:prstGeom prst="rect">
+            <a:avLst/>
+          </a:prstGeom>
+          <a:noFill/>
+          <a:ln/>
+        </p:spPr>
+        <p:txBody>
+          <a:bodyPr wrap="square" lIns="0" tIns="0" rIns="0" bIns="0" rtlCol="0" anchor="ctr"/>
+          <a:lstStyle/>
+          <a:p>
+            <a:pPr algn="ctr" indent="0" marL="0">
+              <a:buNone/>
+            </a:pPr>
+            <a:r>
+              <a:rPr lang="en-US" sz="8800" b="1" dirty="0">
                 <a:solidFill>
                   <a:srgbClr val="F8FAFC"/>
                 </a:solidFill>
@@ -23423,9 +23657,9 @@
                 <a:ea typeface="Calibri" pitchFamily="34" charset="-122"/>
                 <a:cs typeface="Calibri" pitchFamily="34" charset="-120"/>
               </a:rPr>
-              <a:t>Your turn — feedback &amp; Q&amp;A</a:t>
-            </a:r>
-            <a:endParaRPr lang="en-US" sz="4800" dirty="0"/>
+              <a:t>Q&amp;A  time</a:t>
+            </a:r>
+            <a:endParaRPr lang="en-US" sz="8800" dirty="0"/>
           </a:p>
         </p:txBody>
       </p:sp>
@@ -23437,1017 +23671,60 @@
         </p:nvSpPr>
         <p:spPr>
           <a:xfrm>
-            <a:off x="822960" y="3291840"/>
-            <a:ext cx="6400800" cy="3017520"/>
-          </a:xfrm>
-          <a:prstGeom prst="rect">
-            <a:avLst/>
-          </a:prstGeom>
-          <a:solidFill>
-            <a:srgbClr val="1A2853">
-              <a:alpha val="65000"/>
-            </a:srgbClr>
-          </a:solidFill>
-          <a:ln/>
-          <a:effectLst>
-            <a:outerShdw sx="100000" sy="100000" kx="0" ky="0" algn="bl" rotWithShape="0" blurRad="76200" dist="25400" dir="5400000">
-              <a:srgbClr val="000000">
-                <a:alpha val="35000"/>
-              </a:srgbClr>
-            </a:outerShdw>
-          </a:effectLst>
-        </p:spPr>
-      </p:sp>
-      <p:sp>
-        <p:nvSpPr>
-          <p:cNvPr id="36" name="Shape 34"/>
-          <p:cNvSpPr/>
-          <p:nvPr/>
-        </p:nvSpPr>
-        <p:spPr>
-          <a:xfrm>
-            <a:off x="822960" y="3291840"/>
-            <a:ext cx="54864" cy="3017520"/>
-          </a:xfrm>
-          <a:prstGeom prst="rect">
-            <a:avLst/>
-          </a:prstGeom>
-          <a:solidFill>
-            <a:srgbClr val="5EE7FF"/>
-          </a:solidFill>
-          <a:ln/>
-        </p:spPr>
+            <a:off x="4998568" y="4434840"/>
+            <a:ext cx="2194560" cy="54864"/>
+          </a:xfrm>
+          <a:prstGeom prst="rect">
+            <a:avLst/>
+          </a:prstGeom>
+          <a:solidFill>
+            <a:srgbClr val="4F6BFF"/>
+          </a:solidFill>
+          <a:ln/>
+        </p:spPr>
+      </p:sp>
+      <p:sp>
+        <p:nvSpPr>
+          <p:cNvPr id="36" name="Text 34"/>
+          <p:cNvSpPr/>
+          <p:nvPr/>
+        </p:nvSpPr>
+        <p:spPr>
+          <a:xfrm>
+            <a:off x="0" y="4617720"/>
+            <a:ext cx="12191695" cy="457200"/>
+          </a:xfrm>
+          <a:prstGeom prst="rect">
+            <a:avLst/>
+          </a:prstGeom>
+          <a:noFill/>
+          <a:ln/>
+        </p:spPr>
+        <p:txBody>
+          <a:bodyPr wrap="square" lIns="0" tIns="0" rIns="0" bIns="0" rtlCol="0" anchor="ctr"/>
+          <a:lstStyle/>
+          <a:p>
+            <a:pPr algn="ctr" indent="0" marL="0">
+              <a:buNone/>
+            </a:pPr>
+            <a:r>
+              <a:rPr lang="en-US" sz="1800" i="1" dirty="0">
+                <a:solidFill>
+                  <a:srgbClr val="C7D2FE"/>
+                </a:solidFill>
+                <a:latin typeface="Calibri" pitchFamily="34" charset="0"/>
+                <a:ea typeface="Calibri" pitchFamily="34" charset="-122"/>
+                <a:cs typeface="Calibri" pitchFamily="34" charset="-120"/>
+              </a:rPr>
+              <a:t>Feedback welcome — happy to dig into anything</a:t>
+            </a:r>
+            <a:endParaRPr lang="en-US" sz="1800" dirty="0"/>
+          </a:p>
+        </p:txBody>
       </p:sp>
       <p:sp>
         <p:nvSpPr>
           <p:cNvPr id="37" name="Text 35"/>
-          <p:cNvSpPr/>
-          <p:nvPr/>
-        </p:nvSpPr>
-        <p:spPr>
-          <a:xfrm>
-            <a:off x="1051560" y="3474720"/>
-            <a:ext cx="6035040" cy="274320"/>
-          </a:xfrm>
-          <a:prstGeom prst="rect">
-            <a:avLst/>
-          </a:prstGeom>
-          <a:noFill/>
-          <a:ln/>
-        </p:spPr>
-        <p:txBody>
-          <a:bodyPr wrap="square" lIns="0" tIns="0" rIns="0" bIns="0" rtlCol="0" anchor="ctr"/>
-          <a:lstStyle/>
-          <a:p>
-            <a:pPr indent="0" marL="0">
-              <a:buNone/>
-            </a:pPr>
-            <a:r>
-              <a:rPr lang="en-US" sz="1100" b="1" spc="400" kern="0" dirty="0">
-                <a:solidFill>
-                  <a:srgbClr val="5EE7FF"/>
-                </a:solidFill>
-                <a:latin typeface="Calibri" pitchFamily="34" charset="0"/>
-                <a:ea typeface="Calibri" pitchFamily="34" charset="-122"/>
-                <a:cs typeface="Calibri" pitchFamily="34" charset="-120"/>
-              </a:rPr>
-              <a:t>FEEDBACK  WELCOME</a:t>
-            </a:r>
-            <a:endParaRPr lang="en-US" sz="1100" dirty="0"/>
-          </a:p>
-        </p:txBody>
-      </p:sp>
-      <p:sp>
-        <p:nvSpPr>
-          <p:cNvPr id="38" name="Text 36"/>
-          <p:cNvSpPr/>
-          <p:nvPr/>
-        </p:nvSpPr>
-        <p:spPr>
-          <a:xfrm>
-            <a:off x="1051560" y="3749040"/>
-            <a:ext cx="6035040" cy="365760"/>
-          </a:xfrm>
-          <a:prstGeom prst="rect">
-            <a:avLst/>
-          </a:prstGeom>
-          <a:noFill/>
-          <a:ln/>
-        </p:spPr>
-        <p:txBody>
-          <a:bodyPr wrap="square" lIns="0" tIns="0" rIns="0" bIns="0" rtlCol="0" anchor="ctr"/>
-          <a:lstStyle/>
-          <a:p>
-            <a:pPr indent="0" marL="0">
-              <a:buNone/>
-            </a:pPr>
-            <a:r>
-              <a:rPr lang="en-US" sz="1400" i="1" dirty="0">
-                <a:solidFill>
-                  <a:srgbClr val="C7D2FE"/>
-                </a:solidFill>
-                <a:latin typeface="Calibri" pitchFamily="34" charset="0"/>
-                <a:ea typeface="Calibri" pitchFamily="34" charset="-122"/>
-                <a:cs typeface="Calibri" pitchFamily="34" charset="-120"/>
-              </a:rPr>
-              <a:t>Three things I'd love your read on</a:t>
-            </a:r>
-            <a:endParaRPr lang="en-US" sz="1400" dirty="0"/>
-          </a:p>
-        </p:txBody>
-      </p:sp>
-      <p:sp>
-        <p:nvSpPr>
-          <p:cNvPr id="39" name="Shape 37"/>
-          <p:cNvSpPr/>
-          <p:nvPr/>
-        </p:nvSpPr>
-        <p:spPr>
-          <a:xfrm>
-            <a:off x="1051560" y="4343400"/>
-            <a:ext cx="329184" cy="329184"/>
-          </a:xfrm>
-          <a:prstGeom prst="ellipse">
-            <a:avLst/>
-          </a:prstGeom>
-          <a:solidFill>
-            <a:srgbClr val="4F6BFF"/>
-          </a:solidFill>
-          <a:ln/>
-        </p:spPr>
-      </p:sp>
-      <p:sp>
-        <p:nvSpPr>
-          <p:cNvPr id="40" name="Text 38"/>
-          <p:cNvSpPr/>
-          <p:nvPr/>
-        </p:nvSpPr>
-        <p:spPr>
-          <a:xfrm>
-            <a:off x="1051560" y="4343400"/>
-            <a:ext cx="329184" cy="329184"/>
-          </a:xfrm>
-          <a:prstGeom prst="rect">
-            <a:avLst/>
-          </a:prstGeom>
-          <a:noFill/>
-          <a:ln/>
-        </p:spPr>
-        <p:txBody>
-          <a:bodyPr wrap="square" lIns="0" tIns="0" rIns="0" bIns="0" rtlCol="0" anchor="ctr"/>
-          <a:lstStyle/>
-          <a:p>
-            <a:pPr algn="ctr" indent="0" marL="0">
-              <a:buNone/>
-            </a:pPr>
-            <a:r>
-              <a:rPr lang="en-US" sz="1100" b="1" dirty="0">
-                <a:solidFill>
-                  <a:srgbClr val="F8FAFC"/>
-                </a:solidFill>
-                <a:latin typeface="Calibri" pitchFamily="34" charset="0"/>
-                <a:ea typeface="Calibri" pitchFamily="34" charset="-122"/>
-                <a:cs typeface="Calibri" pitchFamily="34" charset="-120"/>
-              </a:rPr>
-              <a:t>1</a:t>
-            </a:r>
-            <a:endParaRPr lang="en-US" sz="1100" dirty="0"/>
-          </a:p>
-        </p:txBody>
-      </p:sp>
-      <p:sp>
-        <p:nvSpPr>
-          <p:cNvPr id="41" name="Text 39"/>
-          <p:cNvSpPr/>
-          <p:nvPr/>
-        </p:nvSpPr>
-        <p:spPr>
-          <a:xfrm>
-            <a:off x="1508760" y="4251960"/>
-            <a:ext cx="5486400" cy="292608"/>
-          </a:xfrm>
-          <a:prstGeom prst="rect">
-            <a:avLst/>
-          </a:prstGeom>
-          <a:noFill/>
-          <a:ln/>
-        </p:spPr>
-        <p:txBody>
-          <a:bodyPr wrap="square" lIns="0" tIns="0" rIns="0" bIns="0" rtlCol="0" anchor="ctr"/>
-          <a:lstStyle/>
-          <a:p>
-            <a:pPr indent="0" marL="0">
-              <a:buNone/>
-            </a:pPr>
-            <a:r>
-              <a:rPr lang="en-US" sz="1400" b="1" dirty="0">
-                <a:solidFill>
-                  <a:srgbClr val="F8FAFC"/>
-                </a:solidFill>
-                <a:latin typeface="Calibri" pitchFamily="34" charset="0"/>
-                <a:ea typeface="Calibri" pitchFamily="34" charset="-122"/>
-                <a:cs typeface="Calibri" pitchFamily="34" charset="-120"/>
-              </a:rPr>
-              <a:t>Locator strategy</a:t>
-            </a:r>
-            <a:endParaRPr lang="en-US" sz="1400" dirty="0"/>
-          </a:p>
-        </p:txBody>
-      </p:sp>
-      <p:sp>
-        <p:nvSpPr>
-          <p:cNvPr id="42" name="Text 40"/>
-          <p:cNvSpPr/>
-          <p:nvPr/>
-        </p:nvSpPr>
-        <p:spPr>
-          <a:xfrm>
-            <a:off x="1508760" y="4544568"/>
-            <a:ext cx="5486400" cy="274320"/>
-          </a:xfrm>
-          <a:prstGeom prst="rect">
-            <a:avLst/>
-          </a:prstGeom>
-          <a:noFill/>
-          <a:ln/>
-        </p:spPr>
-        <p:txBody>
-          <a:bodyPr wrap="square" lIns="0" tIns="0" rIns="0" bIns="0" rtlCol="0" anchor="ctr"/>
-          <a:lstStyle/>
-          <a:p>
-            <a:pPr indent="0" marL="0">
-              <a:buNone/>
-            </a:pPr>
-            <a:r>
-              <a:rPr lang="en-US" sz="1100" dirty="0">
-                <a:solidFill>
-                  <a:srgbClr val="C7D2FE"/>
-                </a:solidFill>
-                <a:latin typeface="Calibri" pitchFamily="34" charset="0"/>
-                <a:ea typeface="Calibri" pitchFamily="34" charset="-122"/>
-                <a:cs typeface="Calibri" pitchFamily="34" charset="-120"/>
-              </a:rPr>
-              <a:t>Did the 4-tier hierarchy land?</a:t>
-            </a:r>
-            <a:endParaRPr lang="en-US" sz="1100" dirty="0"/>
-          </a:p>
-        </p:txBody>
-      </p:sp>
-      <p:sp>
-        <p:nvSpPr>
-          <p:cNvPr id="43" name="Shape 41"/>
-          <p:cNvSpPr/>
-          <p:nvPr/>
-        </p:nvSpPr>
-        <p:spPr>
-          <a:xfrm>
-            <a:off x="1051560" y="4983480"/>
-            <a:ext cx="329184" cy="329184"/>
-          </a:xfrm>
-          <a:prstGeom prst="ellipse">
-            <a:avLst/>
-          </a:prstGeom>
-          <a:solidFill>
-            <a:srgbClr val="4F6BFF"/>
-          </a:solidFill>
-          <a:ln/>
-        </p:spPr>
-      </p:sp>
-      <p:sp>
-        <p:nvSpPr>
-          <p:cNvPr id="44" name="Text 42"/>
-          <p:cNvSpPr/>
-          <p:nvPr/>
-        </p:nvSpPr>
-        <p:spPr>
-          <a:xfrm>
-            <a:off x="1051560" y="4983480"/>
-            <a:ext cx="329184" cy="329184"/>
-          </a:xfrm>
-          <a:prstGeom prst="rect">
-            <a:avLst/>
-          </a:prstGeom>
-          <a:noFill/>
-          <a:ln/>
-        </p:spPr>
-        <p:txBody>
-          <a:bodyPr wrap="square" lIns="0" tIns="0" rIns="0" bIns="0" rtlCol="0" anchor="ctr"/>
-          <a:lstStyle/>
-          <a:p>
-            <a:pPr algn="ctr" indent="0" marL="0">
-              <a:buNone/>
-            </a:pPr>
-            <a:r>
-              <a:rPr lang="en-US" sz="1100" b="1" dirty="0">
-                <a:solidFill>
-                  <a:srgbClr val="F8FAFC"/>
-                </a:solidFill>
-                <a:latin typeface="Calibri" pitchFamily="34" charset="0"/>
-                <a:ea typeface="Calibri" pitchFamily="34" charset="-122"/>
-                <a:cs typeface="Calibri" pitchFamily="34" charset="-120"/>
-              </a:rPr>
-              <a:t>2</a:t>
-            </a:r>
-            <a:endParaRPr lang="en-US" sz="1100" dirty="0"/>
-          </a:p>
-        </p:txBody>
-      </p:sp>
-      <p:sp>
-        <p:nvSpPr>
-          <p:cNvPr id="45" name="Text 43"/>
-          <p:cNvSpPr/>
-          <p:nvPr/>
-        </p:nvSpPr>
-        <p:spPr>
-          <a:xfrm>
-            <a:off x="1508760" y="4892040"/>
-            <a:ext cx="5486400" cy="292608"/>
-          </a:xfrm>
-          <a:prstGeom prst="rect">
-            <a:avLst/>
-          </a:prstGeom>
-          <a:noFill/>
-          <a:ln/>
-        </p:spPr>
-        <p:txBody>
-          <a:bodyPr wrap="square" lIns="0" tIns="0" rIns="0" bIns="0" rtlCol="0" anchor="ctr"/>
-          <a:lstStyle/>
-          <a:p>
-            <a:pPr indent="0" marL="0">
-              <a:buNone/>
-            </a:pPr>
-            <a:r>
-              <a:rPr lang="en-US" sz="1400" b="1" dirty="0">
-                <a:solidFill>
-                  <a:srgbClr val="F8FAFC"/>
-                </a:solidFill>
-                <a:latin typeface="Calibri" pitchFamily="34" charset="0"/>
-                <a:ea typeface="Calibri" pitchFamily="34" charset="-122"/>
-                <a:cs typeface="Calibri" pitchFamily="34" charset="-120"/>
-              </a:rPr>
-              <a:t>Senior-signal tests</a:t>
-            </a:r>
-            <a:endParaRPr lang="en-US" sz="1400" dirty="0"/>
-          </a:p>
-        </p:txBody>
-      </p:sp>
-      <p:sp>
-        <p:nvSpPr>
-          <p:cNvPr id="46" name="Text 44"/>
-          <p:cNvSpPr/>
-          <p:nvPr/>
-        </p:nvSpPr>
-        <p:spPr>
-          <a:xfrm>
-            <a:off x="1508760" y="5184648"/>
-            <a:ext cx="5486400" cy="274320"/>
-          </a:xfrm>
-          <a:prstGeom prst="rect">
-            <a:avLst/>
-          </a:prstGeom>
-          <a:noFill/>
-          <a:ln/>
-        </p:spPr>
-        <p:txBody>
-          <a:bodyPr wrap="square" lIns="0" tIns="0" rIns="0" bIns="0" rtlCol="0" anchor="ctr"/>
-          <a:lstStyle/>
-          <a:p>
-            <a:pPr indent="0" marL="0">
-              <a:buNone/>
-            </a:pPr>
-            <a:r>
-              <a:rPr lang="en-US" sz="1100" dirty="0">
-                <a:solidFill>
-                  <a:srgbClr val="C7D2FE"/>
-                </a:solidFill>
-                <a:latin typeface="Calibri" pitchFamily="34" charset="0"/>
-                <a:ea typeface="Calibri" pitchFamily="34" charset="-122"/>
-                <a:cs typeface="Calibri" pitchFamily="34" charset="-120"/>
-              </a:rPr>
-              <a:t>Do the Everstage parallels hit?</a:t>
-            </a:r>
-            <a:endParaRPr lang="en-US" sz="1100" dirty="0"/>
-          </a:p>
-        </p:txBody>
-      </p:sp>
-      <p:sp>
-        <p:nvSpPr>
-          <p:cNvPr id="47" name="Shape 45"/>
-          <p:cNvSpPr/>
-          <p:nvPr/>
-        </p:nvSpPr>
-        <p:spPr>
-          <a:xfrm>
-            <a:off x="1051560" y="5623560"/>
-            <a:ext cx="329184" cy="329184"/>
-          </a:xfrm>
-          <a:prstGeom prst="ellipse">
-            <a:avLst/>
-          </a:prstGeom>
-          <a:solidFill>
-            <a:srgbClr val="4F6BFF"/>
-          </a:solidFill>
-          <a:ln/>
-        </p:spPr>
-      </p:sp>
-      <p:sp>
-        <p:nvSpPr>
-          <p:cNvPr id="48" name="Text 46"/>
-          <p:cNvSpPr/>
-          <p:nvPr/>
-        </p:nvSpPr>
-        <p:spPr>
-          <a:xfrm>
-            <a:off x="1051560" y="5623560"/>
-            <a:ext cx="329184" cy="329184"/>
-          </a:xfrm>
-          <a:prstGeom prst="rect">
-            <a:avLst/>
-          </a:prstGeom>
-          <a:noFill/>
-          <a:ln/>
-        </p:spPr>
-        <p:txBody>
-          <a:bodyPr wrap="square" lIns="0" tIns="0" rIns="0" bIns="0" rtlCol="0" anchor="ctr"/>
-          <a:lstStyle/>
-          <a:p>
-            <a:pPr algn="ctr" indent="0" marL="0">
-              <a:buNone/>
-            </a:pPr>
-            <a:r>
-              <a:rPr lang="en-US" sz="1100" b="1" dirty="0">
-                <a:solidFill>
-                  <a:srgbClr val="F8FAFC"/>
-                </a:solidFill>
-                <a:latin typeface="Calibri" pitchFamily="34" charset="0"/>
-                <a:ea typeface="Calibri" pitchFamily="34" charset="-122"/>
-                <a:cs typeface="Calibri" pitchFamily="34" charset="-120"/>
-              </a:rPr>
-              <a:t>3</a:t>
-            </a:r>
-            <a:endParaRPr lang="en-US" sz="1100" dirty="0"/>
-          </a:p>
-        </p:txBody>
-      </p:sp>
-      <p:sp>
-        <p:nvSpPr>
-          <p:cNvPr id="49" name="Text 47"/>
-          <p:cNvSpPr/>
-          <p:nvPr/>
-        </p:nvSpPr>
-        <p:spPr>
-          <a:xfrm>
-            <a:off x="1508760" y="5532120"/>
-            <a:ext cx="5486400" cy="292608"/>
-          </a:xfrm>
-          <a:prstGeom prst="rect">
-            <a:avLst/>
-          </a:prstGeom>
-          <a:noFill/>
-          <a:ln/>
-        </p:spPr>
-        <p:txBody>
-          <a:bodyPr wrap="square" lIns="0" tIns="0" rIns="0" bIns="0" rtlCol="0" anchor="ctr"/>
-          <a:lstStyle/>
-          <a:p>
-            <a:pPr indent="0" marL="0">
-              <a:buNone/>
-            </a:pPr>
-            <a:r>
-              <a:rPr lang="en-US" sz="1400" b="1" dirty="0">
-                <a:solidFill>
-                  <a:srgbClr val="F8FAFC"/>
-                </a:solidFill>
-                <a:latin typeface="Calibri" pitchFamily="34" charset="0"/>
-                <a:ea typeface="Calibri" pitchFamily="34" charset="-122"/>
-                <a:cs typeface="Calibri" pitchFamily="34" charset="-120"/>
-              </a:rPr>
-              <a:t>What's missing?</a:t>
-            </a:r>
-            <a:endParaRPr lang="en-US" sz="1400" dirty="0"/>
-          </a:p>
-        </p:txBody>
-      </p:sp>
-      <p:sp>
-        <p:nvSpPr>
-          <p:cNvPr id="50" name="Text 48"/>
-          <p:cNvSpPr/>
-          <p:nvPr/>
-        </p:nvSpPr>
-        <p:spPr>
-          <a:xfrm>
-            <a:off x="1508760" y="5824728"/>
-            <a:ext cx="5486400" cy="274320"/>
-          </a:xfrm>
-          <a:prstGeom prst="rect">
-            <a:avLst/>
-          </a:prstGeom>
-          <a:noFill/>
-          <a:ln/>
-        </p:spPr>
-        <p:txBody>
-          <a:bodyPr wrap="square" lIns="0" tIns="0" rIns="0" bIns="0" rtlCol="0" anchor="ctr"/>
-          <a:lstStyle/>
-          <a:p>
-            <a:pPr indent="0" marL="0">
-              <a:buNone/>
-            </a:pPr>
-            <a:r>
-              <a:rPr lang="en-US" sz="1100" dirty="0">
-                <a:solidFill>
-                  <a:srgbClr val="C7D2FE"/>
-                </a:solidFill>
-                <a:latin typeface="Calibri" pitchFamily="34" charset="0"/>
-                <a:ea typeface="Calibri" pitchFamily="34" charset="-122"/>
-                <a:cs typeface="Calibri" pitchFamily="34" charset="-120"/>
-              </a:rPr>
-              <a:t>Anything I'd need for production?</a:t>
-            </a:r>
-            <a:endParaRPr lang="en-US" sz="1100" dirty="0"/>
-          </a:p>
-        </p:txBody>
-      </p:sp>
-      <p:sp>
-        <p:nvSpPr>
-          <p:cNvPr id="51" name="Shape 49"/>
-          <p:cNvSpPr/>
-          <p:nvPr/>
-        </p:nvSpPr>
-        <p:spPr>
-          <a:xfrm>
-            <a:off x="7498080" y="3291840"/>
-            <a:ext cx="3749040" cy="3017520"/>
-          </a:xfrm>
-          <a:prstGeom prst="rect">
-            <a:avLst/>
-          </a:prstGeom>
-          <a:solidFill>
-            <a:srgbClr val="1A2853">
-              <a:alpha val="65000"/>
-            </a:srgbClr>
-          </a:solidFill>
-          <a:ln/>
-          <a:effectLst>
-            <a:outerShdw sx="100000" sy="100000" kx="0" ky="0" algn="bl" rotWithShape="0" blurRad="76200" dist="25400" dir="5400000">
-              <a:srgbClr val="000000">
-                <a:alpha val="35000"/>
-              </a:srgbClr>
-            </a:outerShdw>
-          </a:effectLst>
-        </p:spPr>
-      </p:sp>
-      <p:sp>
-        <p:nvSpPr>
-          <p:cNvPr id="52" name="Shape 50"/>
-          <p:cNvSpPr/>
-          <p:nvPr/>
-        </p:nvSpPr>
-        <p:spPr>
-          <a:xfrm>
-            <a:off x="7498080" y="3291840"/>
-            <a:ext cx="54864" cy="3017520"/>
-          </a:xfrm>
-          <a:prstGeom prst="rect">
-            <a:avLst/>
-          </a:prstGeom>
-          <a:solidFill>
-            <a:srgbClr val="4F6BFF"/>
-          </a:solidFill>
-          <a:ln/>
-        </p:spPr>
-      </p:sp>
-      <p:sp>
-        <p:nvSpPr>
-          <p:cNvPr id="53" name="Text 51"/>
-          <p:cNvSpPr/>
-          <p:nvPr/>
-        </p:nvSpPr>
-        <p:spPr>
-          <a:xfrm>
-            <a:off x="7726680" y="3474720"/>
-            <a:ext cx="3383280" cy="274320"/>
-          </a:xfrm>
-          <a:prstGeom prst="rect">
-            <a:avLst/>
-          </a:prstGeom>
-          <a:noFill/>
-          <a:ln/>
-        </p:spPr>
-        <p:txBody>
-          <a:bodyPr wrap="square" lIns="0" tIns="0" rIns="0" bIns="0" rtlCol="0" anchor="ctr"/>
-          <a:lstStyle/>
-          <a:p>
-            <a:pPr indent="0" marL="0">
-              <a:buNone/>
-            </a:pPr>
-            <a:r>
-              <a:rPr lang="en-US" sz="1100" b="1" spc="400" kern="0" dirty="0">
-                <a:solidFill>
-                  <a:srgbClr val="4F6BFF"/>
-                </a:solidFill>
-                <a:latin typeface="Calibri" pitchFamily="34" charset="0"/>
-                <a:ea typeface="Calibri" pitchFamily="34" charset="-122"/>
-                <a:cs typeface="Calibri" pitchFamily="34" charset="-120"/>
-              </a:rPr>
-              <a:t>RESOURCES</a:t>
-            </a:r>
-            <a:endParaRPr lang="en-US" sz="1100" dirty="0"/>
-          </a:p>
-        </p:txBody>
-      </p:sp>
-      <p:sp>
-        <p:nvSpPr>
-          <p:cNvPr id="54" name="Text 52"/>
-          <p:cNvSpPr/>
-          <p:nvPr/>
-        </p:nvSpPr>
-        <p:spPr>
-          <a:xfrm>
-            <a:off x="7726680" y="3886200"/>
-            <a:ext cx="1005840" cy="274320"/>
-          </a:xfrm>
-          <a:prstGeom prst="rect">
-            <a:avLst/>
-          </a:prstGeom>
-          <a:noFill/>
-          <a:ln/>
-        </p:spPr>
-        <p:txBody>
-          <a:bodyPr wrap="square" lIns="0" tIns="0" rIns="0" bIns="0" rtlCol="0" anchor="ctr"/>
-          <a:lstStyle/>
-          <a:p>
-            <a:pPr indent="0" marL="0">
-              <a:buNone/>
-            </a:pPr>
-            <a:r>
-              <a:rPr lang="en-US" sz="1000" b="1" dirty="0">
-                <a:solidFill>
-                  <a:srgbClr val="5EE7FF"/>
-                </a:solidFill>
-                <a:latin typeface="Calibri" pitchFamily="34" charset="0"/>
-                <a:ea typeface="Calibri" pitchFamily="34" charset="-122"/>
-                <a:cs typeface="Calibri" pitchFamily="34" charset="-120"/>
-              </a:rPr>
-              <a:t>Repo</a:t>
-            </a:r>
-            <a:endParaRPr lang="en-US" sz="1000" dirty="0"/>
-          </a:p>
-        </p:txBody>
-      </p:sp>
-      <p:sp>
-        <p:nvSpPr>
-          <p:cNvPr id="55" name="Text 53"/>
-          <p:cNvSpPr/>
-          <p:nvPr/>
-        </p:nvSpPr>
-        <p:spPr>
-          <a:xfrm>
-            <a:off x="8732520" y="3886200"/>
-            <a:ext cx="2377440" cy="274320"/>
-          </a:xfrm>
-          <a:prstGeom prst="rect">
-            <a:avLst/>
-          </a:prstGeom>
-          <a:noFill/>
-          <a:ln/>
-        </p:spPr>
-        <p:txBody>
-          <a:bodyPr wrap="square" lIns="0" tIns="0" rIns="0" bIns="0" rtlCol="0" anchor="ctr"/>
-          <a:lstStyle/>
-          <a:p>
-            <a:pPr indent="0" marL="0">
-              <a:buNone/>
-            </a:pPr>
-            <a:r>
-              <a:rPr lang="en-US" sz="950" dirty="0">
-                <a:solidFill>
-                  <a:srgbClr val="C7D2FE"/>
-                </a:solidFill>
-                <a:latin typeface="Courier New" pitchFamily="34" charset="0"/>
-                <a:ea typeface="Courier New" pitchFamily="34" charset="-122"/>
-                <a:cs typeface="Courier New" pitchFamily="34" charset="-120"/>
-              </a:rPr>
-              <a:t>github.com/&lt;you&gt;/EverStage</a:t>
-            </a:r>
-            <a:endParaRPr lang="en-US" sz="950" dirty="0"/>
-          </a:p>
-        </p:txBody>
-      </p:sp>
-      <p:sp>
-        <p:nvSpPr>
-          <p:cNvPr id="56" name="Text 54"/>
-          <p:cNvSpPr/>
-          <p:nvPr/>
-        </p:nvSpPr>
-        <p:spPr>
-          <a:xfrm>
-            <a:off x="7726680" y="4297680"/>
-            <a:ext cx="1005840" cy="274320"/>
-          </a:xfrm>
-          <a:prstGeom prst="rect">
-            <a:avLst/>
-          </a:prstGeom>
-          <a:noFill/>
-          <a:ln/>
-        </p:spPr>
-        <p:txBody>
-          <a:bodyPr wrap="square" lIns="0" tIns="0" rIns="0" bIns="0" rtlCol="0" anchor="ctr"/>
-          <a:lstStyle/>
-          <a:p>
-            <a:pPr indent="0" marL="0">
-              <a:buNone/>
-            </a:pPr>
-            <a:r>
-              <a:rPr lang="en-US" sz="1000" b="1" dirty="0">
-                <a:solidFill>
-                  <a:srgbClr val="5EE7FF"/>
-                </a:solidFill>
-                <a:latin typeface="Calibri" pitchFamily="34" charset="0"/>
-                <a:ea typeface="Calibri" pitchFamily="34" charset="-122"/>
-                <a:cs typeface="Calibri" pitchFamily="34" charset="-120"/>
-              </a:rPr>
-              <a:t>Rich report</a:t>
-            </a:r>
-            <a:endParaRPr lang="en-US" sz="1000" dirty="0"/>
-          </a:p>
-        </p:txBody>
-      </p:sp>
-      <p:sp>
-        <p:nvSpPr>
-          <p:cNvPr id="57" name="Text 55"/>
-          <p:cNvSpPr/>
-          <p:nvPr/>
-        </p:nvSpPr>
-        <p:spPr>
-          <a:xfrm>
-            <a:off x="8732520" y="4297680"/>
-            <a:ext cx="2377440" cy="274320"/>
-          </a:xfrm>
-          <a:prstGeom prst="rect">
-            <a:avLst/>
-          </a:prstGeom>
-          <a:noFill/>
-          <a:ln/>
-        </p:spPr>
-        <p:txBody>
-          <a:bodyPr wrap="square" lIns="0" tIns="0" rIns="0" bIns="0" rtlCol="0" anchor="ctr"/>
-          <a:lstStyle/>
-          <a:p>
-            <a:pPr indent="0" marL="0">
-              <a:buNone/>
-            </a:pPr>
-            <a:r>
-              <a:rPr lang="en-US" sz="950" dirty="0">
-                <a:solidFill>
-                  <a:srgbClr val="C7D2FE"/>
-                </a:solidFill>
-                <a:latin typeface="Courier New" pitchFamily="34" charset="0"/>
-                <a:ea typeface="Courier New" pitchFamily="34" charset="-122"/>
-                <a:cs typeface="Courier New" pitchFamily="34" charset="-120"/>
-              </a:rPr>
-              <a:t>npm run report:rich</a:t>
-            </a:r>
-            <a:endParaRPr lang="en-US" sz="950" dirty="0"/>
-          </a:p>
-        </p:txBody>
-      </p:sp>
-      <p:sp>
-        <p:nvSpPr>
-          <p:cNvPr id="58" name="Text 56"/>
-          <p:cNvSpPr/>
-          <p:nvPr/>
-        </p:nvSpPr>
-        <p:spPr>
-          <a:xfrm>
-            <a:off x="7726680" y="4709160"/>
-            <a:ext cx="1005840" cy="274320"/>
-          </a:xfrm>
-          <a:prstGeom prst="rect">
-            <a:avLst/>
-          </a:prstGeom>
-          <a:noFill/>
-          <a:ln/>
-        </p:spPr>
-        <p:txBody>
-          <a:bodyPr wrap="square" lIns="0" tIns="0" rIns="0" bIns="0" rtlCol="0" anchor="ctr"/>
-          <a:lstStyle/>
-          <a:p>
-            <a:pPr indent="0" marL="0">
-              <a:buNone/>
-            </a:pPr>
-            <a:r>
-              <a:rPr lang="en-US" sz="1000" b="1" dirty="0">
-                <a:solidFill>
-                  <a:srgbClr val="5EE7FF"/>
-                </a:solidFill>
-                <a:latin typeface="Calibri" pitchFamily="34" charset="0"/>
-                <a:ea typeface="Calibri" pitchFamily="34" charset="-122"/>
-                <a:cs typeface="Calibri" pitchFamily="34" charset="-120"/>
-              </a:rPr>
-              <a:t>Test plan</a:t>
-            </a:r>
-            <a:endParaRPr lang="en-US" sz="1000" dirty="0"/>
-          </a:p>
-        </p:txBody>
-      </p:sp>
-      <p:sp>
-        <p:nvSpPr>
-          <p:cNvPr id="59" name="Text 57"/>
-          <p:cNvSpPr/>
-          <p:nvPr/>
-        </p:nvSpPr>
-        <p:spPr>
-          <a:xfrm>
-            <a:off x="8732520" y="4709160"/>
-            <a:ext cx="2377440" cy="274320"/>
-          </a:xfrm>
-          <a:prstGeom prst="rect">
-            <a:avLst/>
-          </a:prstGeom>
-          <a:noFill/>
-          <a:ln/>
-        </p:spPr>
-        <p:txBody>
-          <a:bodyPr wrap="square" lIns="0" tIns="0" rIns="0" bIns="0" rtlCol="0" anchor="ctr"/>
-          <a:lstStyle/>
-          <a:p>
-            <a:pPr indent="0" marL="0">
-              <a:buNone/>
-            </a:pPr>
-            <a:r>
-              <a:rPr lang="en-US" sz="950" dirty="0">
-                <a:solidFill>
-                  <a:srgbClr val="C7D2FE"/>
-                </a:solidFill>
-                <a:latin typeface="Courier New" pitchFamily="34" charset="0"/>
-                <a:ea typeface="Courier New" pitchFamily="34" charset="-122"/>
-                <a:cs typeface="Courier New" pitchFamily="34" charset="-120"/>
-              </a:rPr>
-              <a:t>docs/EVERSTAGE-TEST-PLAN.md</a:t>
-            </a:r>
-            <a:endParaRPr lang="en-US" sz="950" dirty="0"/>
-          </a:p>
-        </p:txBody>
-      </p:sp>
-      <p:sp>
-        <p:nvSpPr>
-          <p:cNvPr id="60" name="Text 58"/>
-          <p:cNvSpPr/>
-          <p:nvPr/>
-        </p:nvSpPr>
-        <p:spPr>
-          <a:xfrm>
-            <a:off x="7726680" y="5120640"/>
-            <a:ext cx="1005840" cy="274320"/>
-          </a:xfrm>
-          <a:prstGeom prst="rect">
-            <a:avLst/>
-          </a:prstGeom>
-          <a:noFill/>
-          <a:ln/>
-        </p:spPr>
-        <p:txBody>
-          <a:bodyPr wrap="square" lIns="0" tIns="0" rIns="0" bIns="0" rtlCol="0" anchor="ctr"/>
-          <a:lstStyle/>
-          <a:p>
-            <a:pPr indent="0" marL="0">
-              <a:buNone/>
-            </a:pPr>
-            <a:r>
-              <a:rPr lang="en-US" sz="1000" b="1" dirty="0">
-                <a:solidFill>
-                  <a:srgbClr val="5EE7FF"/>
-                </a:solidFill>
-                <a:latin typeface="Calibri" pitchFamily="34" charset="0"/>
-                <a:ea typeface="Calibri" pitchFamily="34" charset="-122"/>
-                <a:cs typeface="Calibri" pitchFamily="34" charset="-120"/>
-              </a:rPr>
-              <a:t>Code tour</a:t>
-            </a:r>
-            <a:endParaRPr lang="en-US" sz="1000" dirty="0"/>
-          </a:p>
-        </p:txBody>
-      </p:sp>
-      <p:sp>
-        <p:nvSpPr>
-          <p:cNvPr id="61" name="Text 59"/>
-          <p:cNvSpPr/>
-          <p:nvPr/>
-        </p:nvSpPr>
-        <p:spPr>
-          <a:xfrm>
-            <a:off x="8732520" y="5120640"/>
-            <a:ext cx="2377440" cy="274320"/>
-          </a:xfrm>
-          <a:prstGeom prst="rect">
-            <a:avLst/>
-          </a:prstGeom>
-          <a:noFill/>
-          <a:ln/>
-        </p:spPr>
-        <p:txBody>
-          <a:bodyPr wrap="square" lIns="0" tIns="0" rIns="0" bIns="0" rtlCol="0" anchor="ctr"/>
-          <a:lstStyle/>
-          <a:p>
-            <a:pPr indent="0" marL="0">
-              <a:buNone/>
-            </a:pPr>
-            <a:r>
-              <a:rPr lang="en-US" sz="950" dirty="0">
-                <a:solidFill>
-                  <a:srgbClr val="C7D2FE"/>
-                </a:solidFill>
-                <a:latin typeface="Courier New" pitchFamily="34" charset="0"/>
-                <a:ea typeface="Courier New" pitchFamily="34" charset="-122"/>
-                <a:cs typeface="Courier New" pitchFamily="34" charset="-120"/>
-              </a:rPr>
-              <a:t>docs/CODE-TOUR.md</a:t>
-            </a:r>
-            <a:endParaRPr lang="en-US" sz="950" dirty="0"/>
-          </a:p>
-        </p:txBody>
-      </p:sp>
-      <p:sp>
-        <p:nvSpPr>
-          <p:cNvPr id="62" name="Text 60"/>
-          <p:cNvSpPr/>
-          <p:nvPr/>
-        </p:nvSpPr>
-        <p:spPr>
-          <a:xfrm>
-            <a:off x="7726680" y="5532120"/>
-            <a:ext cx="1005840" cy="274320"/>
-          </a:xfrm>
-          <a:prstGeom prst="rect">
-            <a:avLst/>
-          </a:prstGeom>
-          <a:noFill/>
-          <a:ln/>
-        </p:spPr>
-        <p:txBody>
-          <a:bodyPr wrap="square" lIns="0" tIns="0" rIns="0" bIns="0" rtlCol="0" anchor="ctr"/>
-          <a:lstStyle/>
-          <a:p>
-            <a:pPr indent="0" marL="0">
-              <a:buNone/>
-            </a:pPr>
-            <a:r>
-              <a:rPr lang="en-US" sz="1000" b="1" dirty="0">
-                <a:solidFill>
-                  <a:srgbClr val="5EE7FF"/>
-                </a:solidFill>
-                <a:latin typeface="Calibri" pitchFamily="34" charset="0"/>
-                <a:ea typeface="Calibri" pitchFamily="34" charset="-122"/>
-                <a:cs typeface="Calibri" pitchFamily="34" charset="-120"/>
-              </a:rPr>
-              <a:t>Demo doc</a:t>
-            </a:r>
-            <a:endParaRPr lang="en-US" sz="1000" dirty="0"/>
-          </a:p>
-        </p:txBody>
-      </p:sp>
-      <p:sp>
-        <p:nvSpPr>
-          <p:cNvPr id="63" name="Text 61"/>
-          <p:cNvSpPr/>
-          <p:nvPr/>
-        </p:nvSpPr>
-        <p:spPr>
-          <a:xfrm>
-            <a:off x="8732520" y="5532120"/>
-            <a:ext cx="2377440" cy="274320"/>
-          </a:xfrm>
-          <a:prstGeom prst="rect">
-            <a:avLst/>
-          </a:prstGeom>
-          <a:noFill/>
-          <a:ln/>
-        </p:spPr>
-        <p:txBody>
-          <a:bodyPr wrap="square" lIns="0" tIns="0" rIns="0" bIns="0" rtlCol="0" anchor="ctr"/>
-          <a:lstStyle/>
-          <a:p>
-            <a:pPr indent="0" marL="0">
-              <a:buNone/>
-            </a:pPr>
-            <a:r>
-              <a:rPr lang="en-US" sz="950" dirty="0">
-                <a:solidFill>
-                  <a:srgbClr val="C7D2FE"/>
-                </a:solidFill>
-                <a:latin typeface="Courier New" pitchFamily="34" charset="0"/>
-                <a:ea typeface="Courier New" pitchFamily="34" charset="-122"/>
-                <a:cs typeface="Courier New" pitchFamily="34" charset="-120"/>
-              </a:rPr>
-              <a:t>docs/DEEP-TEST-REPORT.md</a:t>
-            </a:r>
-            <a:endParaRPr lang="en-US" sz="950" dirty="0"/>
-          </a:p>
-        </p:txBody>
-      </p:sp>
-      <p:sp>
-        <p:nvSpPr>
-          <p:cNvPr id="64" name="Text 62"/>
           <p:cNvSpPr/>
           <p:nvPr/>
         </p:nvSpPr>

</xml_diff>